<commit_message>
Enter the date of the announcement
</commit_message>
<xml_diff>
--- a/20250530/Spring Cacheでパフォーマンスを向上させよう.pptx
+++ b/20250530/Spring Cacheでパフォーマンスを向上させよう.pptx
@@ -1209,7 +1209,7 @@
           <a:p>
             <a:fld id="{B5C59BA4-7C1B-4DE2-B397-F366871A932A}" type="datetimeFigureOut">
               <a:rPr kumimoji="1" lang="ja-JP" altLang="en-US" smtClean="0"/>
-              <a:t>2025/4/5</a:t>
+              <a:t>2025/5/2</a:t>
             </a:fld>
             <a:endParaRPr kumimoji="1" lang="ja-JP" altLang="en-US"/>
           </a:p>
@@ -2917,7 +2917,7 @@
             </a:r>
             <a:r>
               <a:rPr kumimoji="1" lang="en-US" altLang="ja-JP" sz="1600" dirty="0"/>
-              <a:t>1.0</a:t>
+              <a:t>2.0</a:t>
             </a:r>
             <a:r>
               <a:rPr kumimoji="1" lang="ja-JP" altLang="en-US" sz="1600" dirty="0"/>
@@ -2933,7 +2933,7 @@
             </a:r>
             <a:r>
               <a:rPr kumimoji="1" lang="en-US" altLang="ja-JP" sz="1600" dirty="0"/>
-              <a:t>04</a:t>
+              <a:t>05</a:t>
             </a:r>
             <a:r>
               <a:rPr kumimoji="1" lang="ja-JP" altLang="en-US" sz="1600" dirty="0"/>
@@ -2941,7 +2941,7 @@
             </a:r>
             <a:r>
               <a:rPr kumimoji="1" lang="en-US" altLang="ja-JP" sz="1600" dirty="0"/>
-              <a:t>XX</a:t>
+              <a:t>30</a:t>
             </a:r>
             <a:r>
               <a:rPr kumimoji="1" lang="ja-JP" altLang="en-US" sz="1600" dirty="0"/>
@@ -12103,6 +12103,15 @@
 </file>
 
 <file path=customXml/item1.xml><?xml version="1.0" encoding="utf-8"?>
+<?mso-contentType ?>
+<FormTemplates xmlns="http://schemas.microsoft.com/sharepoint/v3/contenttype/forms">
+  <Display>DocumentLibraryForm</Display>
+  <Edit>DocumentLibraryForm</Edit>
+  <New>DocumentLibraryForm</New>
+</FormTemplates>
+</file>
+
+<file path=customXml/item2.xml><?xml version="1.0" encoding="utf-8"?>
 <p:properties xmlns:p="http://schemas.microsoft.com/office/2006/metadata/properties" xmlns:xsi="http://www.w3.org/2001/XMLSchema-instance" xmlns:pc="http://schemas.microsoft.com/office/infopath/2007/PartnerControls">
   <documentManagement>
     <SharedWithUsers xmlns="dda6833c-0046-4f8f-9c83-6e1ad4a6ae00">
@@ -12114,15 +12123,6 @@
     </SharedWithUsers>
   </documentManagement>
 </p:properties>
-</file>
-
-<file path=customXml/item2.xml><?xml version="1.0" encoding="utf-8"?>
-<?mso-contentType ?>
-<FormTemplates xmlns="http://schemas.microsoft.com/sharepoint/v3/contenttype/forms">
-  <Display>DocumentLibraryForm</Display>
-  <Edit>DocumentLibraryForm</Edit>
-  <New>DocumentLibraryForm</New>
-</FormTemplates>
 </file>
 
 <file path=customXml/item3.xml><?xml version="1.0" encoding="utf-8"?>
@@ -12305,6 +12305,14 @@
 </file>
 
 <file path=customXml/itemProps1.xml><?xml version="1.0" encoding="utf-8"?>
+<ds:datastoreItem xmlns:ds="http://schemas.openxmlformats.org/officeDocument/2006/customXml" ds:itemID="{AA5A7698-7A98-4CC4-9FFF-A34D3B1004C6}">
+  <ds:schemaRefs>
+    <ds:schemaRef ds:uri="http://schemas.microsoft.com/sharepoint/v3/contenttype/forms"/>
+  </ds:schemaRefs>
+</ds:datastoreItem>
+</file>
+
+<file path=customXml/itemProps2.xml><?xml version="1.0" encoding="utf-8"?>
 <ds:datastoreItem xmlns:ds="http://schemas.openxmlformats.org/officeDocument/2006/customXml" ds:itemID="{AFD2C487-7431-40FA-A912-1148C9736568}">
   <ds:schemaRefs>
     <ds:schemaRef ds:uri="http://schemas.microsoft.com/office/2006/documentManagement/types"/>
@@ -12317,14 +12325,6 @@
     <ds:schemaRef ds:uri="http://schemas.microsoft.com/office/infopath/2007/PartnerControls"/>
     <ds:schemaRef ds:uri="dda6833c-0046-4f8f-9c83-6e1ad4a6ae00"/>
     <ds:schemaRef ds:uri="http://www.w3.org/XML/1998/namespace"/>
-  </ds:schemaRefs>
-</ds:datastoreItem>
-</file>
-
-<file path=customXml/itemProps2.xml><?xml version="1.0" encoding="utf-8"?>
-<ds:datastoreItem xmlns:ds="http://schemas.openxmlformats.org/officeDocument/2006/customXml" ds:itemID="{AA5A7698-7A98-4CC4-9FFF-A34D3B1004C6}">
-  <ds:schemaRefs>
-    <ds:schemaRef ds:uri="http://schemas.microsoft.com/sharepoint/v3/contenttype/forms"/>
   </ds:schemaRefs>
 </ds:datastoreItem>
 </file>

</xml_diff>